<commit_message>
Polish all 32 session decks: cleaner cards, aligned bullets, fix final-week closing
- Replace left accent stripes on concept and checklist cards with
  accent dots / check-circles (edge stripes read as AI-generated filler)
- Tighten concept-card height and vertically center the block
- Align project-slide bullet dots with their text
- Final week (32) closing now reads 'Program complete → job-ready'
  instead of pointing to a non-existent Week 33
</commit_message>
<xml_diff>
--- a/Month-01-Foundations-and-Identity-Protocols/Week-01-Cloud-Networking/W1_Cloud_Networking.pptx
+++ b/Month-01-Foundations-and-Identity-Protocols/Week-01-Cloud-Networking/W1_Cloud_Networking.pptx
@@ -2192,7 +2192,7 @@
         <p:spPr>
           <a:xfrm>
             <a:off x="640080" y="4206240"/>
-            <a:ext cx="9144000" cy="457200"/>
+            <a:ext cx="10515600" cy="457200"/>
           </a:xfrm>
           <a:prstGeom prst="rect">
             <a:avLst/>
@@ -3679,12 +3679,12 @@
         </p:nvSpPr>
         <p:spPr>
           <a:xfrm>
-            <a:off x="548640" y="1572768"/>
-            <a:ext cx="5440680" cy="2194560"/>
+            <a:off x="548640" y="1984248"/>
+            <a:ext cx="5440680" cy="1828800"/>
           </a:xfrm>
           <a:prstGeom prst="roundRect">
             <a:avLst>
-              <a:gd name="adj" fmla="val 2917"/>
+              <a:gd name="adj" fmla="val 3500"/>
             </a:avLst>
           </a:prstGeom>
           <a:solidFill>
@@ -3713,13 +3713,11 @@
         </p:nvSpPr>
         <p:spPr>
           <a:xfrm>
-            <a:off x="548640" y="1572768"/>
-            <a:ext cx="128016" cy="2194560"/>
-          </a:xfrm>
-          <a:prstGeom prst="roundRect">
-            <a:avLst>
-              <a:gd name="adj" fmla="val 35714"/>
-            </a:avLst>
+            <a:off x="841248" y="2240280"/>
+            <a:ext cx="182880" cy="182880"/>
+          </a:xfrm>
+          <a:prstGeom prst="ellipse">
+            <a:avLst/>
           </a:prstGeom>
           <a:solidFill>
             <a:srgbClr val="2FA6E0"/>
@@ -3735,8 +3733,8 @@
         </p:nvSpPr>
         <p:spPr>
           <a:xfrm>
-            <a:off x="841248" y="1700784"/>
-            <a:ext cx="4983480" cy="411480"/>
+            <a:off x="1152144" y="2130552"/>
+            <a:ext cx="4663440" cy="411480"/>
           </a:xfrm>
           <a:prstGeom prst="rect">
             <a:avLst/>
@@ -3771,8 +3769,8 @@
         </p:nvSpPr>
         <p:spPr>
           <a:xfrm>
-            <a:off x="841248" y="2121408"/>
-            <a:ext cx="4937760" cy="1536192"/>
+            <a:off x="859536" y="2642616"/>
+            <a:ext cx="4892040" cy="1042416"/>
           </a:xfrm>
           <a:prstGeom prst="rect">
             <a:avLst/>
@@ -3786,7 +3784,7 @@
           <a:p>
             <a:pPr indent="0" marL="0">
               <a:lnSpc>
-                <a:spcPct val="102000"/>
+                <a:spcPct val="105000"/>
               </a:lnSpc>
               <a:buNone/>
             </a:pPr>
@@ -3810,12 +3808,12 @@
         </p:nvSpPr>
         <p:spPr>
           <a:xfrm>
-            <a:off x="6309360" y="1572768"/>
-            <a:ext cx="5440680" cy="2194560"/>
+            <a:off x="6309360" y="1984248"/>
+            <a:ext cx="5440680" cy="1828800"/>
           </a:xfrm>
           <a:prstGeom prst="roundRect">
             <a:avLst>
-              <a:gd name="adj" fmla="val 2917"/>
+              <a:gd name="adj" fmla="val 3500"/>
             </a:avLst>
           </a:prstGeom>
           <a:solidFill>
@@ -3844,13 +3842,11 @@
         </p:nvSpPr>
         <p:spPr>
           <a:xfrm>
-            <a:off x="6309360" y="1572768"/>
-            <a:ext cx="128016" cy="2194560"/>
-          </a:xfrm>
-          <a:prstGeom prst="roundRect">
-            <a:avLst>
-              <a:gd name="adj" fmla="val 35714"/>
-            </a:avLst>
+            <a:off x="6601968" y="2240280"/>
+            <a:ext cx="182880" cy="182880"/>
+          </a:xfrm>
+          <a:prstGeom prst="ellipse">
+            <a:avLst/>
           </a:prstGeom>
           <a:solidFill>
             <a:srgbClr val="2FA6E0"/>
@@ -3866,8 +3862,8 @@
         </p:nvSpPr>
         <p:spPr>
           <a:xfrm>
-            <a:off x="6601968" y="1700784"/>
-            <a:ext cx="4983480" cy="411480"/>
+            <a:off x="6912864" y="2130552"/>
+            <a:ext cx="4663440" cy="411480"/>
           </a:xfrm>
           <a:prstGeom prst="rect">
             <a:avLst/>
@@ -3902,8 +3898,8 @@
         </p:nvSpPr>
         <p:spPr>
           <a:xfrm>
-            <a:off x="6601968" y="2121408"/>
-            <a:ext cx="4937760" cy="1536192"/>
+            <a:off x="6620256" y="2642616"/>
+            <a:ext cx="4892040" cy="1042416"/>
           </a:xfrm>
           <a:prstGeom prst="rect">
             <a:avLst/>
@@ -3917,7 +3913,7 @@
           <a:p>
             <a:pPr indent="0" marL="0">
               <a:lnSpc>
-                <a:spcPct val="102000"/>
+                <a:spcPct val="105000"/>
               </a:lnSpc>
               <a:buNone/>
             </a:pPr>
@@ -3941,12 +3937,12 @@
         </p:nvSpPr>
         <p:spPr>
           <a:xfrm>
-            <a:off x="548640" y="3968496"/>
-            <a:ext cx="5440680" cy="2194560"/>
+            <a:off x="548640" y="4087368"/>
+            <a:ext cx="5440680" cy="1828800"/>
           </a:xfrm>
           <a:prstGeom prst="roundRect">
             <a:avLst>
-              <a:gd name="adj" fmla="val 2917"/>
+              <a:gd name="adj" fmla="val 3500"/>
             </a:avLst>
           </a:prstGeom>
           <a:solidFill>
@@ -3975,13 +3971,11 @@
         </p:nvSpPr>
         <p:spPr>
           <a:xfrm>
-            <a:off x="548640" y="3968496"/>
-            <a:ext cx="128016" cy="2194560"/>
-          </a:xfrm>
-          <a:prstGeom prst="roundRect">
-            <a:avLst>
-              <a:gd name="adj" fmla="val 35714"/>
-            </a:avLst>
+            <a:off x="841248" y="4343400"/>
+            <a:ext cx="182880" cy="182880"/>
+          </a:xfrm>
+          <a:prstGeom prst="ellipse">
+            <a:avLst/>
           </a:prstGeom>
           <a:solidFill>
             <a:srgbClr val="2FA6E0"/>
@@ -3997,8 +3991,8 @@
         </p:nvSpPr>
         <p:spPr>
           <a:xfrm>
-            <a:off x="841248" y="4096512"/>
-            <a:ext cx="4983480" cy="411480"/>
+            <a:off x="1152144" y="4233672"/>
+            <a:ext cx="4663440" cy="411480"/>
           </a:xfrm>
           <a:prstGeom prst="rect">
             <a:avLst/>
@@ -4033,8 +4027,8 @@
         </p:nvSpPr>
         <p:spPr>
           <a:xfrm>
-            <a:off x="841248" y="4517136"/>
-            <a:ext cx="4937760" cy="1536192"/>
+            <a:off x="859536" y="4745736"/>
+            <a:ext cx="4892040" cy="1042416"/>
           </a:xfrm>
           <a:prstGeom prst="rect">
             <a:avLst/>
@@ -4048,7 +4042,7 @@
           <a:p>
             <a:pPr indent="0" marL="0">
               <a:lnSpc>
-                <a:spcPct val="102000"/>
+                <a:spcPct val="105000"/>
               </a:lnSpc>
               <a:buNone/>
             </a:pPr>
@@ -4072,12 +4066,12 @@
         </p:nvSpPr>
         <p:spPr>
           <a:xfrm>
-            <a:off x="6309360" y="3968496"/>
-            <a:ext cx="5440680" cy="2194560"/>
+            <a:off x="6309360" y="4087368"/>
+            <a:ext cx="5440680" cy="1828800"/>
           </a:xfrm>
           <a:prstGeom prst="roundRect">
             <a:avLst>
-              <a:gd name="adj" fmla="val 2917"/>
+              <a:gd name="adj" fmla="val 3500"/>
             </a:avLst>
           </a:prstGeom>
           <a:solidFill>
@@ -4106,13 +4100,11 @@
         </p:nvSpPr>
         <p:spPr>
           <a:xfrm>
-            <a:off x="6309360" y="3968496"/>
-            <a:ext cx="128016" cy="2194560"/>
-          </a:xfrm>
-          <a:prstGeom prst="roundRect">
-            <a:avLst>
-              <a:gd name="adj" fmla="val 35714"/>
-            </a:avLst>
+            <a:off x="6601968" y="4343400"/>
+            <a:ext cx="182880" cy="182880"/>
+          </a:xfrm>
+          <a:prstGeom prst="ellipse">
+            <a:avLst/>
           </a:prstGeom>
           <a:solidFill>
             <a:srgbClr val="2FA6E0"/>
@@ -4128,8 +4120,8 @@
         </p:nvSpPr>
         <p:spPr>
           <a:xfrm>
-            <a:off x="6601968" y="4096512"/>
-            <a:ext cx="4983480" cy="411480"/>
+            <a:off x="6912864" y="4233672"/>
+            <a:ext cx="4663440" cy="411480"/>
           </a:xfrm>
           <a:prstGeom prst="rect">
             <a:avLst/>
@@ -4164,8 +4156,8 @@
         </p:nvSpPr>
         <p:spPr>
           <a:xfrm>
-            <a:off x="6601968" y="4517136"/>
-            <a:ext cx="4937760" cy="1536192"/>
+            <a:off x="6620256" y="4745736"/>
+            <a:ext cx="4892040" cy="1042416"/>
           </a:xfrm>
           <a:prstGeom prst="rect">
             <a:avLst/>
@@ -4179,7 +4171,7 @@
           <a:p>
             <a:pPr indent="0" marL="0">
               <a:lnSpc>
-                <a:spcPct val="102000"/>
+                <a:spcPct val="105000"/>
               </a:lnSpc>
               <a:buNone/>
             </a:pPr>
@@ -6516,10 +6508,10 @@
         </p:nvSpPr>
         <p:spPr>
           <a:xfrm>
-            <a:off x="6400800" y="2377440"/>
-            <a:ext cx="91440" cy="676656"/>
-          </a:xfrm>
-          <a:prstGeom prst="rect">
+            <a:off x="6601968" y="2560320"/>
+            <a:ext cx="310896" cy="310896"/>
+          </a:xfrm>
+          <a:prstGeom prst="ellipse">
             <a:avLst/>
           </a:prstGeom>
           <a:solidFill>
@@ -6536,8 +6528,8 @@
         </p:nvSpPr>
         <p:spPr>
           <a:xfrm>
-            <a:off x="6510528" y="2377440"/>
-            <a:ext cx="457200" cy="676656"/>
+            <a:off x="6601968" y="2560320"/>
+            <a:ext cx="310896" cy="310896"/>
           </a:xfrm>
           <a:prstGeom prst="rect">
             <a:avLst/>
@@ -6553,14 +6545,14 @@
               <a:buNone/>
             </a:pPr>
             <a:r>
-              <a:rPr lang="en-US" sz="1600" dirty="0">
-                <a:solidFill>
-                  <a:srgbClr val="17C3B2"/>
-                </a:solidFill>
-              </a:rPr>
-              <a:t>☑</a:t>
-            </a:r>
-            <a:endParaRPr lang="en-US" sz="1600" dirty="0"/>
+              <a:rPr lang="en-US" sz="1400" b="1" dirty="0">
+                <a:solidFill>
+                  <a:srgbClr val="FFFFFF"/>
+                </a:solidFill>
+              </a:rPr>
+              <a:t>✓</a:t>
+            </a:r>
+            <a:endParaRPr lang="en-US" sz="1400" dirty="0"/>
           </a:p>
         </p:txBody>
       </p:sp>
@@ -6635,10 +6627,10 @@
         </p:nvSpPr>
         <p:spPr>
           <a:xfrm>
-            <a:off x="6400800" y="3182112"/>
-            <a:ext cx="91440" cy="676656"/>
-          </a:xfrm>
-          <a:prstGeom prst="rect">
+            <a:off x="6601968" y="3364992"/>
+            <a:ext cx="310896" cy="310896"/>
+          </a:xfrm>
+          <a:prstGeom prst="ellipse">
             <a:avLst/>
           </a:prstGeom>
           <a:solidFill>
@@ -6655,8 +6647,8 @@
         </p:nvSpPr>
         <p:spPr>
           <a:xfrm>
-            <a:off x="6510528" y="3182112"/>
-            <a:ext cx="457200" cy="676656"/>
+            <a:off x="6601968" y="3364992"/>
+            <a:ext cx="310896" cy="310896"/>
           </a:xfrm>
           <a:prstGeom prst="rect">
             <a:avLst/>
@@ -6672,14 +6664,14 @@
               <a:buNone/>
             </a:pPr>
             <a:r>
-              <a:rPr lang="en-US" sz="1600" dirty="0">
-                <a:solidFill>
-                  <a:srgbClr val="17C3B2"/>
-                </a:solidFill>
-              </a:rPr>
-              <a:t>☑</a:t>
-            </a:r>
-            <a:endParaRPr lang="en-US" sz="1600" dirty="0"/>
+              <a:rPr lang="en-US" sz="1400" b="1" dirty="0">
+                <a:solidFill>
+                  <a:srgbClr val="FFFFFF"/>
+                </a:solidFill>
+              </a:rPr>
+              <a:t>✓</a:t>
+            </a:r>
+            <a:endParaRPr lang="en-US" sz="1400" dirty="0"/>
           </a:p>
         </p:txBody>
       </p:sp>
@@ -6754,10 +6746,10 @@
         </p:nvSpPr>
         <p:spPr>
           <a:xfrm>
-            <a:off x="6400800" y="3986784"/>
-            <a:ext cx="91440" cy="676656"/>
-          </a:xfrm>
-          <a:prstGeom prst="rect">
+            <a:off x="6601968" y="4169664"/>
+            <a:ext cx="310896" cy="310896"/>
+          </a:xfrm>
+          <a:prstGeom prst="ellipse">
             <a:avLst/>
           </a:prstGeom>
           <a:solidFill>
@@ -6774,8 +6766,8 @@
         </p:nvSpPr>
         <p:spPr>
           <a:xfrm>
-            <a:off x="6510528" y="3986784"/>
-            <a:ext cx="457200" cy="676656"/>
+            <a:off x="6601968" y="4169664"/>
+            <a:ext cx="310896" cy="310896"/>
           </a:xfrm>
           <a:prstGeom prst="rect">
             <a:avLst/>
@@ -6791,14 +6783,14 @@
               <a:buNone/>
             </a:pPr>
             <a:r>
-              <a:rPr lang="en-US" sz="1600" dirty="0">
-                <a:solidFill>
-                  <a:srgbClr val="17C3B2"/>
-                </a:solidFill>
-              </a:rPr>
-              <a:t>☑</a:t>
-            </a:r>
-            <a:endParaRPr lang="en-US" sz="1600" dirty="0"/>
+              <a:rPr lang="en-US" sz="1400" b="1" dirty="0">
+                <a:solidFill>
+                  <a:srgbClr val="FFFFFF"/>
+                </a:solidFill>
+              </a:rPr>
+              <a:t>✓</a:t>
+            </a:r>
+            <a:endParaRPr lang="en-US" sz="1400" dirty="0"/>
           </a:p>
         </p:txBody>
       </p:sp>
@@ -6873,10 +6865,10 @@
         </p:nvSpPr>
         <p:spPr>
           <a:xfrm>
-            <a:off x="6400800" y="4791456"/>
-            <a:ext cx="91440" cy="676656"/>
-          </a:xfrm>
-          <a:prstGeom prst="rect">
+            <a:off x="6601968" y="4974336"/>
+            <a:ext cx="310896" cy="310896"/>
+          </a:xfrm>
+          <a:prstGeom prst="ellipse">
             <a:avLst/>
           </a:prstGeom>
           <a:solidFill>
@@ -6893,8 +6885,8 @@
         </p:nvSpPr>
         <p:spPr>
           <a:xfrm>
-            <a:off x="6510528" y="4791456"/>
-            <a:ext cx="457200" cy="676656"/>
+            <a:off x="6601968" y="4974336"/>
+            <a:ext cx="310896" cy="310896"/>
           </a:xfrm>
           <a:prstGeom prst="rect">
             <a:avLst/>
@@ -6910,14 +6902,14 @@
               <a:buNone/>
             </a:pPr>
             <a:r>
-              <a:rPr lang="en-US" sz="1600" dirty="0">
-                <a:solidFill>
-                  <a:srgbClr val="17C3B2"/>
-                </a:solidFill>
-              </a:rPr>
-              <a:t>☑</a:t>
-            </a:r>
-            <a:endParaRPr lang="en-US" sz="1600" dirty="0"/>
+              <a:rPr lang="en-US" sz="1400" b="1" dirty="0">
+                <a:solidFill>
+                  <a:srgbClr val="FFFFFF"/>
+                </a:solidFill>
+              </a:rPr>
+              <a:t>✓</a:t>
+            </a:r>
+            <a:endParaRPr lang="en-US" sz="1400" dirty="0"/>
           </a:p>
         </p:txBody>
       </p:sp>
@@ -7491,7 +7483,7 @@
         </p:nvSpPr>
         <p:spPr>
           <a:xfrm>
-            <a:off x="594360" y="2980944"/>
+            <a:off x="594360" y="3118104"/>
             <a:ext cx="146304" cy="146304"/>
           </a:xfrm>
           <a:prstGeom prst="ellipse">
@@ -7512,7 +7504,7 @@
         <p:spPr>
           <a:xfrm>
             <a:off x="868680" y="2926080"/>
-            <a:ext cx="5074920" cy="548640"/>
+            <a:ext cx="5074920" cy="530352"/>
           </a:xfrm>
           <a:prstGeom prst="rect">
             <a:avLst/>
@@ -7547,7 +7539,7 @@
         </p:nvSpPr>
         <p:spPr>
           <a:xfrm>
-            <a:off x="594360" y="3547872"/>
+            <a:off x="594360" y="3685032"/>
             <a:ext cx="146304" cy="146304"/>
           </a:xfrm>
           <a:prstGeom prst="ellipse">
@@ -7568,7 +7560,7 @@
         <p:spPr>
           <a:xfrm>
             <a:off x="868680" y="3493008"/>
-            <a:ext cx="5074920" cy="548640"/>
+            <a:ext cx="5074920" cy="530352"/>
           </a:xfrm>
           <a:prstGeom prst="rect">
             <a:avLst/>
@@ -7603,7 +7595,7 @@
         </p:nvSpPr>
         <p:spPr>
           <a:xfrm>
-            <a:off x="594360" y="4114800"/>
+            <a:off x="594360" y="4251960"/>
             <a:ext cx="146304" cy="146304"/>
           </a:xfrm>
           <a:prstGeom prst="ellipse">
@@ -7624,7 +7616,7 @@
         <p:spPr>
           <a:xfrm>
             <a:off x="868680" y="4059936"/>
-            <a:ext cx="5074920" cy="548640"/>
+            <a:ext cx="5074920" cy="530352"/>
           </a:xfrm>
           <a:prstGeom prst="rect">
             <a:avLst/>
@@ -7659,7 +7651,7 @@
         </p:nvSpPr>
         <p:spPr>
           <a:xfrm>
-            <a:off x="594360" y="4681728"/>
+            <a:off x="594360" y="4818888"/>
             <a:ext cx="146304" cy="146304"/>
           </a:xfrm>
           <a:prstGeom prst="ellipse">
@@ -7680,7 +7672,7 @@
         <p:spPr>
           <a:xfrm>
             <a:off x="868680" y="4626864"/>
-            <a:ext cx="5074920" cy="548640"/>
+            <a:ext cx="5074920" cy="530352"/>
           </a:xfrm>
           <a:prstGeom prst="rect">
             <a:avLst/>
@@ -7715,7 +7707,7 @@
         </p:nvSpPr>
         <p:spPr>
           <a:xfrm>
-            <a:off x="594360" y="5248656"/>
+            <a:off x="594360" y="5385816"/>
             <a:ext cx="146304" cy="146304"/>
           </a:xfrm>
           <a:prstGeom prst="ellipse">
@@ -7736,7 +7728,7 @@
         <p:spPr>
           <a:xfrm>
             <a:off x="868680" y="5193792"/>
-            <a:ext cx="5074920" cy="548640"/>
+            <a:ext cx="5074920" cy="530352"/>
           </a:xfrm>
           <a:prstGeom prst="rect">
             <a:avLst/>
@@ -7771,7 +7763,7 @@
         </p:nvSpPr>
         <p:spPr>
           <a:xfrm>
-            <a:off x="594360" y="5815584"/>
+            <a:off x="594360" y="5952744"/>
             <a:ext cx="146304" cy="146304"/>
           </a:xfrm>
           <a:prstGeom prst="ellipse">
@@ -7792,7 +7784,7 @@
         <p:spPr>
           <a:xfrm>
             <a:off x="868680" y="5760720"/>
-            <a:ext cx="5074920" cy="548640"/>
+            <a:ext cx="5074920" cy="530352"/>
           </a:xfrm>
           <a:prstGeom prst="rect">
             <a:avLst/>

</xml_diff>